<commit_message>
Add milestone trail, reproduction guide, and poster/UI updates
- milestones/: Topics 1-6 deliverables, previously kept outside the repository,
  including the Topic 6 notebook exactly as submitted. PROGRESS.md maps every
  milestone to its deliverable and commits and states plainly that these files
  were added after the fact (their dates are original file dates).
- README: "Reproduce the results" with commands and expected key numbers;
  scripts/run_notebook.py runs the notebook without the jupyter command.
- Dashboard risk score now matches column names ignoring case (the shipped
  sample used Hypertension/SystolicBP and silently showed 0%); two tests.
- Poster rebuilt with a product-tour strip; UI screenshots and capture scripts.

Co-Authored-By: Claude Sonnet 5.5 <noreply@anthropic.com>
</commit_message>
<xml_diff>
--- a/Technology_Capstone_Showcase_Poster.pptx
+++ b/Technology_Capstone_Showcase_Poster.pptx
@@ -3091,7 +3091,7 @@
         <p:spPr>
           <a:xfrm>
             <a:off x="1" y="0"/>
-            <a:ext cx="32918399" cy="6236208"/>
+            <a:ext cx="32918399" cy="5212080"/>
           </a:xfrm>
           <a:prstGeom prst="rect">
             <a:avLst/>
@@ -3126,8 +3126,8 @@
         </p:nvSpPr>
         <p:spPr>
           <a:xfrm>
-            <a:off x="914400" y="640080"/>
-            <a:ext cx="24505920" cy="1920240"/>
+            <a:off x="914400" y="457200"/>
+            <a:ext cx="24505920" cy="1828800"/>
           </a:xfrm>
           <a:prstGeom prst="rect">
             <a:avLst/>
@@ -3168,7 +3168,7 @@
         </p:nvSpPr>
         <p:spPr>
           <a:xfrm>
-            <a:off x="914400" y="2697480"/>
+            <a:off x="914400" y="2011680"/>
             <a:ext cx="24505920" cy="914400"/>
           </a:xfrm>
           <a:prstGeom prst="rect">
@@ -3210,8 +3210,8 @@
         </p:nvSpPr>
         <p:spPr>
           <a:xfrm>
-            <a:off x="914400" y="3977639"/>
-            <a:ext cx="24505920" cy="2011680"/>
+            <a:off x="914400" y="3154680"/>
+            <a:ext cx="24505920" cy="1828800"/>
           </a:xfrm>
           <a:prstGeom prst="rect">
             <a:avLst/>
@@ -3280,8 +3280,8 @@
         </p:nvSpPr>
         <p:spPr>
           <a:xfrm>
-            <a:off x="26243280" y="548640"/>
-            <a:ext cx="5394960" cy="5394960"/>
+            <a:off x="26700480" y="457200"/>
+            <a:ext cx="4754880" cy="4297680"/>
           </a:xfrm>
           <a:prstGeom prst="roundRect">
             <a:avLst>
@@ -3340,8 +3340,8 @@
         </p:blipFill>
         <p:spPr>
           <a:xfrm>
-            <a:off x="26471880" y="777240"/>
-            <a:ext cx="4937760" cy="4937760"/>
+            <a:off x="27020520" y="594360"/>
+            <a:ext cx="4114800" cy="4114800"/>
           </a:xfrm>
           <a:prstGeom prst="rect">
             <a:avLst/>
@@ -3356,7 +3356,7 @@
         </p:nvSpPr>
         <p:spPr>
           <a:xfrm>
-            <a:off x="914400" y="7040880"/>
+            <a:off x="914400" y="6126480"/>
             <a:ext cx="9875520" cy="1234440"/>
           </a:xfrm>
           <a:prstGeom prst="roundRect">
@@ -3411,7 +3411,7 @@
         </p:nvSpPr>
         <p:spPr>
           <a:xfrm>
-            <a:off x="914400" y="8686800"/>
+            <a:off x="914400" y="7772400"/>
             <a:ext cx="9875520" cy="3911600"/>
           </a:xfrm>
           <a:prstGeom prst="rect">
@@ -3490,7 +3490,7 @@
         </p:nvSpPr>
         <p:spPr>
           <a:xfrm>
-            <a:off x="914400" y="12689840"/>
+            <a:off x="914400" y="11775440"/>
             <a:ext cx="2926080" cy="3566160"/>
           </a:xfrm>
           <a:prstGeom prst="roundRect">
@@ -3538,7 +3538,7 @@
         </p:nvSpPr>
         <p:spPr>
           <a:xfrm>
-            <a:off x="1965960" y="12872720"/>
+            <a:off x="1965960" y="11958320"/>
             <a:ext cx="822960" cy="822960"/>
           </a:xfrm>
           <a:prstGeom prst="ellipse">
@@ -3591,7 +3591,7 @@
         </p:nvSpPr>
         <p:spPr>
           <a:xfrm>
-            <a:off x="1005840" y="13832840"/>
+            <a:off x="1005840" y="12918440"/>
             <a:ext cx="2743200" cy="640080"/>
           </a:xfrm>
           <a:prstGeom prst="rect">
@@ -3633,7 +3633,7 @@
         </p:nvSpPr>
         <p:spPr>
           <a:xfrm>
-            <a:off x="1097280" y="14564360"/>
+            <a:off x="1097280" y="13649960"/>
             <a:ext cx="2560320" cy="1645920"/>
           </a:xfrm>
           <a:prstGeom prst="rect">
@@ -3675,7 +3675,7 @@
         </p:nvSpPr>
         <p:spPr>
           <a:xfrm>
-            <a:off x="4389120" y="12689840"/>
+            <a:off x="4389120" y="11775440"/>
             <a:ext cx="2926080" cy="3566160"/>
           </a:xfrm>
           <a:prstGeom prst="roundRect">
@@ -3723,7 +3723,7 @@
         </p:nvSpPr>
         <p:spPr>
           <a:xfrm>
-            <a:off x="5440680" y="12872720"/>
+            <a:off x="5440680" y="11958320"/>
             <a:ext cx="822960" cy="822960"/>
           </a:xfrm>
           <a:prstGeom prst="ellipse">
@@ -3776,7 +3776,7 @@
         </p:nvSpPr>
         <p:spPr>
           <a:xfrm>
-            <a:off x="4480560" y="13832840"/>
+            <a:off x="4480560" y="12918440"/>
             <a:ext cx="2743200" cy="640080"/>
           </a:xfrm>
           <a:prstGeom prst="rect">
@@ -3818,7 +3818,7 @@
         </p:nvSpPr>
         <p:spPr>
           <a:xfrm>
-            <a:off x="4572000" y="14564360"/>
+            <a:off x="4572000" y="13649960"/>
             <a:ext cx="2560320" cy="1645920"/>
           </a:xfrm>
           <a:prstGeom prst="rect">
@@ -3860,7 +3860,7 @@
         </p:nvSpPr>
         <p:spPr>
           <a:xfrm>
-            <a:off x="7863840" y="12689840"/>
+            <a:off x="7863840" y="11775440"/>
             <a:ext cx="2926080" cy="3566160"/>
           </a:xfrm>
           <a:prstGeom prst="roundRect">
@@ -3908,7 +3908,7 @@
         </p:nvSpPr>
         <p:spPr>
           <a:xfrm>
-            <a:off x="8915400" y="12872720"/>
+            <a:off x="8915400" y="11958320"/>
             <a:ext cx="822960" cy="822960"/>
           </a:xfrm>
           <a:prstGeom prst="ellipse">
@@ -3961,7 +3961,7 @@
         </p:nvSpPr>
         <p:spPr>
           <a:xfrm>
-            <a:off x="7955280" y="13832840"/>
+            <a:off x="7955280" y="12918440"/>
             <a:ext cx="2743200" cy="640080"/>
           </a:xfrm>
           <a:prstGeom prst="rect">
@@ -4003,7 +4003,7 @@
         </p:nvSpPr>
         <p:spPr>
           <a:xfrm>
-            <a:off x="8046720" y="14564360"/>
+            <a:off x="8046720" y="13649960"/>
             <a:ext cx="2560320" cy="1645920"/>
           </a:xfrm>
           <a:prstGeom prst="rect">
@@ -4045,7 +4045,7 @@
         </p:nvSpPr>
         <p:spPr>
           <a:xfrm>
-            <a:off x="914400" y="16667480"/>
+            <a:off x="914400" y="15753080"/>
             <a:ext cx="9875520" cy="2997200"/>
           </a:xfrm>
           <a:prstGeom prst="rect">
@@ -4116,15 +4116,144 @@
           </a:p>
         </p:txBody>
       </p:sp>
-      <p:sp>
-        <p:nvSpPr>
-          <p:cNvPr id="24" name="Rounded Rectangle 23"/>
+      <p:pic>
+        <p:nvPicPr>
+          <p:cNvPr id="24" name="Picture 23" descr="tour_1_login.png"/>
+          <p:cNvPicPr>
+            <a:picLocks noChangeAspect="1"/>
+          </p:cNvPicPr>
+          <p:nvPr/>
+        </p:nvPicPr>
+        <p:blipFill>
+          <a:blip r:embed="rId3"/>
+          <a:stretch>
+            <a:fillRect/>
+          </a:stretch>
+        </p:blipFill>
+        <p:spPr>
+          <a:xfrm>
+            <a:off x="914400" y="18841720"/>
+            <a:ext cx="3108960" cy="1829503"/>
+          </a:xfrm>
+          <a:prstGeom prst="rect">
+            <a:avLst/>
+          </a:prstGeom>
+          <a:ln w="31750">
+            <a:solidFill>
+              <a:srgbClr val="D9CCEB"/>
+            </a:solidFill>
+          </a:ln>
+        </p:spPr>
+      </p:pic>
+      <p:pic>
+        <p:nvPicPr>
+          <p:cNvPr id="25" name="Picture 24" descr="tour_2_summary.png"/>
+          <p:cNvPicPr>
+            <a:picLocks noChangeAspect="1"/>
+          </p:cNvPicPr>
+          <p:nvPr/>
+        </p:nvPicPr>
+        <p:blipFill>
+          <a:blip r:embed="rId4"/>
+          <a:stretch>
+            <a:fillRect/>
+          </a:stretch>
+        </p:blipFill>
+        <p:spPr>
+          <a:xfrm>
+            <a:off x="4297679" y="18841720"/>
+            <a:ext cx="3108960" cy="1829845"/>
+          </a:xfrm>
+          <a:prstGeom prst="rect">
+            <a:avLst/>
+          </a:prstGeom>
+          <a:ln w="31750">
+            <a:solidFill>
+              <a:srgbClr val="D9CCEB"/>
+            </a:solidFill>
+          </a:ln>
+        </p:spPr>
+      </p:pic>
+      <p:pic>
+        <p:nvPicPr>
+          <p:cNvPr id="26" name="Picture 25" descr="tour_3_dashboard.png"/>
+          <p:cNvPicPr>
+            <a:picLocks noChangeAspect="1"/>
+          </p:cNvPicPr>
+          <p:nvPr/>
+        </p:nvPicPr>
+        <p:blipFill>
+          <a:blip r:embed="rId5"/>
+          <a:stretch>
+            <a:fillRect/>
+          </a:stretch>
+        </p:blipFill>
+        <p:spPr>
+          <a:xfrm>
+            <a:off x="7680959" y="18841720"/>
+            <a:ext cx="3108960" cy="1829845"/>
+          </a:xfrm>
+          <a:prstGeom prst="rect">
+            <a:avLst/>
+          </a:prstGeom>
+          <a:ln w="31750">
+            <a:solidFill>
+              <a:srgbClr val="D9CCEB"/>
+            </a:solidFill>
+          </a:ln>
+        </p:spPr>
+      </p:pic>
+      <p:sp>
+        <p:nvSpPr>
+          <p:cNvPr id="27" name="TextBox 26"/>
+          <p:cNvSpPr txBox="1"/>
+          <p:nvPr/>
+        </p:nvSpPr>
+        <p:spPr>
+          <a:xfrm>
+            <a:off x="914400" y="20853400"/>
+            <a:ext cx="9875520" cy="1280160"/>
+          </a:xfrm>
+          <a:prstGeom prst="rect">
+            <a:avLst/>
+          </a:prstGeom>
+          <a:noFill/>
+        </p:spPr>
+        <p:txBody>
+          <a:bodyPr wrap="square" anchor="t" lIns="0" rIns="0" tIns="0" bIns="0">
+            <a:spAutoFit/>
+          </a:bodyPr>
+          <a:lstStyle/>
+          <a:p>
+            <a:pPr algn="l">
+              <a:lnSpc>
+                <a:spcPct val="100000"/>
+              </a:lnSpc>
+              <a:spcAft>
+                <a:spcPts val="0"/>
+              </a:spcAft>
+            </a:pPr>
+            <a:r>
+              <a:rPr sz="2500" b="0" i="1">
+                <a:solidFill>
+                  <a:srgbClr val="52606D"/>
+                </a:solidFill>
+                <a:latin typeface="Calibri"/>
+              </a:rPr>
+              <a:t>Screens from the running app: (1) role-based sign-in, (2) data upload with summary statistics, (3) dashboard with a risk score.</a:t>
+            </a:r>
+          </a:p>
+        </p:txBody>
+      </p:sp>
+      <p:sp>
+        <p:nvSpPr>
+          <p:cNvPr id="28" name="Rounded Rectangle 27"/>
           <p:cNvSpPr/>
           <p:nvPr/>
         </p:nvSpPr>
         <p:spPr>
           <a:xfrm>
-            <a:off x="914400" y="20076160"/>
+            <a:off x="914400" y="22453600"/>
             <a:ext cx="9875520" cy="1234440"/>
           </a:xfrm>
           <a:prstGeom prst="roundRect">
@@ -4173,13 +4302,13 @@
       </p:sp>
       <p:sp>
         <p:nvSpPr>
-          <p:cNvPr id="25" name="TextBox 24"/>
+          <p:cNvPr id="29" name="TextBox 28"/>
           <p:cNvSpPr txBox="1"/>
           <p:nvPr/>
         </p:nvSpPr>
         <p:spPr>
           <a:xfrm>
-            <a:off x="914400" y="21722080"/>
+            <a:off x="914400" y="24099520"/>
             <a:ext cx="9875520" cy="3911600"/>
           </a:xfrm>
           <a:prstGeom prst="rect">
@@ -4234,14 +4363,14 @@
       </p:sp>
       <p:sp>
         <p:nvSpPr>
-          <p:cNvPr id="26" name="Rounded Rectangle 25"/>
+          <p:cNvPr id="30" name="Rounded Rectangle 29"/>
           <p:cNvSpPr/>
           <p:nvPr/>
         </p:nvSpPr>
         <p:spPr>
           <a:xfrm>
-            <a:off x="914400" y="25725120"/>
-            <a:ext cx="3108960" cy="2834640"/>
+            <a:off x="914400" y="28102560"/>
+            <a:ext cx="3108960" cy="2560320"/>
           </a:xfrm>
           <a:prstGeom prst="roundRect">
             <a:avLst>
@@ -4282,14 +4411,14 @@
       </p:sp>
       <p:sp>
         <p:nvSpPr>
-          <p:cNvPr id="27" name="TextBox 26"/>
+          <p:cNvPr id="31" name="TextBox 30"/>
           <p:cNvSpPr txBox="1"/>
           <p:nvPr/>
         </p:nvSpPr>
         <p:spPr>
           <a:xfrm>
-            <a:off x="1097280" y="25862280"/>
-            <a:ext cx="2743200" cy="1417320"/>
+            <a:off x="1097280" y="28239720"/>
+            <a:ext cx="2743200" cy="1280160"/>
           </a:xfrm>
           <a:prstGeom prst="rect">
             <a:avLst/>
@@ -4311,7 +4440,7 @@
               </a:spcAft>
             </a:pPr>
             <a:r>
-              <a:rPr sz="6600" b="1" i="0">
+              <a:rPr sz="6400" b="1" i="0">
                 <a:solidFill>
                   <a:srgbClr val="522398"/>
                 </a:solidFill>
@@ -4324,14 +4453,14 @@
       </p:sp>
       <p:sp>
         <p:nvSpPr>
-          <p:cNvPr id="28" name="TextBox 27"/>
+          <p:cNvPr id="32" name="TextBox 31"/>
           <p:cNvSpPr txBox="1"/>
           <p:nvPr/>
         </p:nvSpPr>
         <p:spPr>
           <a:xfrm>
-            <a:off x="1143000" y="27284172"/>
-            <a:ext cx="2651760" cy="1190548"/>
+            <a:off x="1143000" y="29510736"/>
+            <a:ext cx="2651760" cy="1075334"/>
           </a:xfrm>
           <a:prstGeom prst="rect">
             <a:avLst/>
@@ -4366,14 +4495,14 @@
       </p:sp>
       <p:sp>
         <p:nvSpPr>
-          <p:cNvPr id="29" name="Rounded Rectangle 28"/>
+          <p:cNvPr id="33" name="Rounded Rectangle 32"/>
           <p:cNvSpPr/>
           <p:nvPr/>
         </p:nvSpPr>
         <p:spPr>
           <a:xfrm>
-            <a:off x="4297680" y="25725120"/>
-            <a:ext cx="3108960" cy="2834640"/>
+            <a:off x="4297680" y="28102560"/>
+            <a:ext cx="3108960" cy="2560320"/>
           </a:xfrm>
           <a:prstGeom prst="roundRect">
             <a:avLst>
@@ -4414,14 +4543,14 @@
       </p:sp>
       <p:sp>
         <p:nvSpPr>
-          <p:cNvPr id="30" name="TextBox 29"/>
+          <p:cNvPr id="34" name="TextBox 33"/>
           <p:cNvSpPr txBox="1"/>
           <p:nvPr/>
         </p:nvSpPr>
         <p:spPr>
           <a:xfrm>
-            <a:off x="4480560" y="25862280"/>
-            <a:ext cx="2743200" cy="1417320"/>
+            <a:off x="4480560" y="28239720"/>
+            <a:ext cx="2743200" cy="1280160"/>
           </a:xfrm>
           <a:prstGeom prst="rect">
             <a:avLst/>
@@ -4443,7 +4572,7 @@
               </a:spcAft>
             </a:pPr>
             <a:r>
-              <a:rPr sz="6600" b="1" i="0">
+              <a:rPr sz="6400" b="1" i="0">
                 <a:solidFill>
                   <a:srgbClr val="522398"/>
                 </a:solidFill>
@@ -4456,14 +4585,14 @@
       </p:sp>
       <p:sp>
         <p:nvSpPr>
-          <p:cNvPr id="31" name="TextBox 30"/>
+          <p:cNvPr id="35" name="TextBox 34"/>
           <p:cNvSpPr txBox="1"/>
           <p:nvPr/>
         </p:nvSpPr>
         <p:spPr>
           <a:xfrm>
-            <a:off x="4526280" y="27284172"/>
-            <a:ext cx="2651760" cy="1190548"/>
+            <a:off x="4526280" y="29510736"/>
+            <a:ext cx="2651760" cy="1075334"/>
           </a:xfrm>
           <a:prstGeom prst="rect">
             <a:avLst/>
@@ -4498,14 +4627,14 @@
       </p:sp>
       <p:sp>
         <p:nvSpPr>
-          <p:cNvPr id="32" name="Rounded Rectangle 31"/>
+          <p:cNvPr id="36" name="Rounded Rectangle 35"/>
           <p:cNvSpPr/>
           <p:nvPr/>
         </p:nvSpPr>
         <p:spPr>
           <a:xfrm>
-            <a:off x="7680960" y="25725120"/>
-            <a:ext cx="3108960" cy="2834640"/>
+            <a:off x="7680960" y="28102560"/>
+            <a:ext cx="3108960" cy="2560320"/>
           </a:xfrm>
           <a:prstGeom prst="roundRect">
             <a:avLst>
@@ -4546,14 +4675,14 @@
       </p:sp>
       <p:sp>
         <p:nvSpPr>
-          <p:cNvPr id="33" name="TextBox 32"/>
+          <p:cNvPr id="37" name="TextBox 36"/>
           <p:cNvSpPr txBox="1"/>
           <p:nvPr/>
         </p:nvSpPr>
         <p:spPr>
           <a:xfrm>
-            <a:off x="7863840" y="25862280"/>
-            <a:ext cx="2743200" cy="1417320"/>
+            <a:off x="7863840" y="28239720"/>
+            <a:ext cx="2743200" cy="1280160"/>
           </a:xfrm>
           <a:prstGeom prst="rect">
             <a:avLst/>
@@ -4575,7 +4704,7 @@
               </a:spcAft>
             </a:pPr>
             <a:r>
-              <a:rPr sz="6600" b="1" i="0">
+              <a:rPr sz="6400" b="1" i="0">
                 <a:solidFill>
                   <a:srgbClr val="522398"/>
                 </a:solidFill>
@@ -4588,14 +4717,14 @@
       </p:sp>
       <p:sp>
         <p:nvSpPr>
-          <p:cNvPr id="34" name="TextBox 33"/>
+          <p:cNvPr id="38" name="TextBox 37"/>
           <p:cNvSpPr txBox="1"/>
           <p:nvPr/>
         </p:nvSpPr>
         <p:spPr>
           <a:xfrm>
-            <a:off x="7909560" y="27284172"/>
-            <a:ext cx="2651760" cy="1190548"/>
+            <a:off x="7909560" y="29510736"/>
+            <a:ext cx="2651760" cy="1075334"/>
           </a:xfrm>
           <a:prstGeom prst="rect">
             <a:avLst/>
@@ -4630,22 +4759,22 @@
       </p:sp>
       <p:pic>
         <p:nvPicPr>
-          <p:cNvPr id="35" name="Picture 34" descr="topic6_fig8_office_vs_abpm.png"/>
+          <p:cNvPr id="39" name="Picture 38" descr="topic6_fig8_office_vs_abpm.png"/>
           <p:cNvPicPr>
             <a:picLocks noChangeAspect="1"/>
           </p:cNvPicPr>
           <p:nvPr/>
         </p:nvPicPr>
         <p:blipFill>
-          <a:blip r:embed="rId3"/>
+          <a:blip r:embed="rId6"/>
           <a:stretch>
             <a:fillRect/>
           </a:stretch>
         </p:blipFill>
         <p:spPr>
           <a:xfrm>
-            <a:off x="1554480" y="28925520"/>
-            <a:ext cx="8595360" cy="6294290"/>
+            <a:off x="2377440" y="31028640"/>
+            <a:ext cx="6949440" cy="5089000"/>
           </a:xfrm>
           <a:prstGeom prst="rect">
             <a:avLst/>
@@ -4659,13 +4788,13 @@
       </p:pic>
       <p:sp>
         <p:nvSpPr>
-          <p:cNvPr id="36" name="TextBox 35"/>
+          <p:cNvPr id="40" name="TextBox 39"/>
           <p:cNvSpPr txBox="1"/>
           <p:nvPr/>
         </p:nvSpPr>
         <p:spPr>
           <a:xfrm>
-            <a:off x="914400" y="35402690"/>
+            <a:off x="914400" y="36300520"/>
             <a:ext cx="9875520" cy="1280160"/>
           </a:xfrm>
           <a:prstGeom prst="rect">
@@ -4701,13 +4830,13 @@
       </p:sp>
       <p:sp>
         <p:nvSpPr>
-          <p:cNvPr id="37" name="Rounded Rectangle 36"/>
+          <p:cNvPr id="41" name="Rounded Rectangle 40"/>
           <p:cNvSpPr/>
           <p:nvPr/>
         </p:nvSpPr>
         <p:spPr>
           <a:xfrm>
-            <a:off x="11521440" y="7040880"/>
+            <a:off x="11521440" y="6126480"/>
             <a:ext cx="9875520" cy="1234440"/>
           </a:xfrm>
           <a:prstGeom prst="roundRect">
@@ -4756,14 +4885,14 @@
       </p:sp>
       <p:graphicFrame>
         <p:nvGraphicFramePr>
-          <p:cNvPr id="38" name="Table 37"/>
+          <p:cNvPr id="42" name="Table 41"/>
           <p:cNvGraphicFramePr>
             <a:graphicFrameLocks noGrp="1"/>
           </p:cNvGraphicFramePr>
           <p:nvPr/>
         </p:nvGraphicFramePr>
         <p:xfrm>
-          <a:off x="11521440" y="8686800"/>
+          <a:off x="11521440" y="7772400"/>
           <a:ext cx="9875520" cy="9951720"/>
         </p:xfrm>
         <a:graphic>
@@ -5259,13 +5388,13 @@
       </p:graphicFrame>
       <p:sp>
         <p:nvSpPr>
-          <p:cNvPr id="39" name="Rounded Rectangle 38"/>
+          <p:cNvPr id="43" name="Rounded Rectangle 42"/>
           <p:cNvSpPr/>
           <p:nvPr/>
         </p:nvSpPr>
         <p:spPr>
           <a:xfrm>
-            <a:off x="11521440" y="19187160"/>
+            <a:off x="11521440" y="18272760"/>
             <a:ext cx="9875520" cy="1234440"/>
           </a:xfrm>
           <a:prstGeom prst="roundRect">
@@ -5314,13 +5443,13 @@
       </p:sp>
       <p:sp>
         <p:nvSpPr>
-          <p:cNvPr id="40" name="TextBox 39"/>
+          <p:cNvPr id="44" name="TextBox 43"/>
           <p:cNvSpPr txBox="1"/>
           <p:nvPr/>
         </p:nvSpPr>
         <p:spPr>
           <a:xfrm>
-            <a:off x="11521440" y="20833080"/>
+            <a:off x="11521440" y="19918680"/>
             <a:ext cx="9875520" cy="1041400"/>
           </a:xfrm>
           <a:prstGeom prst="rect">
@@ -5356,14 +5485,14 @@
       </p:sp>
       <p:sp>
         <p:nvSpPr>
-          <p:cNvPr id="41" name="Rectangle 40"/>
+          <p:cNvPr id="45" name="Rectangle 44"/>
           <p:cNvSpPr/>
           <p:nvPr/>
         </p:nvSpPr>
         <p:spPr>
           <a:xfrm>
-            <a:off x="11942064" y="22423120"/>
-            <a:ext cx="73152" cy="7315200"/>
+            <a:off x="11942064" y="21508720"/>
+            <a:ext cx="73152" cy="8001000"/>
           </a:xfrm>
           <a:prstGeom prst="rect">
             <a:avLst/>
@@ -5400,13 +5529,13 @@
       </p:sp>
       <p:sp>
         <p:nvSpPr>
-          <p:cNvPr id="42" name="Oval 41"/>
+          <p:cNvPr id="46" name="Oval 45"/>
           <p:cNvSpPr/>
           <p:nvPr/>
         </p:nvSpPr>
         <p:spPr>
           <a:xfrm>
-            <a:off x="11521440" y="21965920"/>
+            <a:off x="11521440" y="21051520"/>
             <a:ext cx="914400" cy="914400"/>
           </a:xfrm>
           <a:prstGeom prst="ellipse">
@@ -5453,14 +5582,14 @@
       </p:sp>
       <p:sp>
         <p:nvSpPr>
-          <p:cNvPr id="43" name="TextBox 42"/>
+          <p:cNvPr id="47" name="TextBox 46"/>
           <p:cNvSpPr txBox="1"/>
           <p:nvPr/>
         </p:nvSpPr>
         <p:spPr>
           <a:xfrm>
-            <a:off x="12801600" y="21920200"/>
-            <a:ext cx="8595360" cy="1463040"/>
+            <a:off x="12801600" y="21005800"/>
+            <a:ext cx="8595360" cy="1600200"/>
           </a:xfrm>
           <a:prstGeom prst="rect">
             <a:avLst/>
@@ -5514,13 +5643,13 @@
       </p:sp>
       <p:sp>
         <p:nvSpPr>
-          <p:cNvPr id="44" name="Oval 43"/>
+          <p:cNvPr id="48" name="Oval 47"/>
           <p:cNvSpPr/>
           <p:nvPr/>
         </p:nvSpPr>
         <p:spPr>
           <a:xfrm>
-            <a:off x="11521440" y="23428960"/>
+            <a:off x="11521440" y="22651720"/>
             <a:ext cx="914400" cy="914400"/>
           </a:xfrm>
           <a:prstGeom prst="ellipse">
@@ -5567,14 +5696,14 @@
       </p:sp>
       <p:sp>
         <p:nvSpPr>
-          <p:cNvPr id="45" name="TextBox 44"/>
+          <p:cNvPr id="49" name="TextBox 48"/>
           <p:cNvSpPr txBox="1"/>
           <p:nvPr/>
         </p:nvSpPr>
         <p:spPr>
           <a:xfrm>
-            <a:off x="12801600" y="23383240"/>
-            <a:ext cx="8595360" cy="1463040"/>
+            <a:off x="12801600" y="22606000"/>
+            <a:ext cx="8595360" cy="1600200"/>
           </a:xfrm>
           <a:prstGeom prst="rect">
             <a:avLst/>
@@ -5628,13 +5757,13 @@
       </p:sp>
       <p:sp>
         <p:nvSpPr>
-          <p:cNvPr id="46" name="Oval 45"/>
+          <p:cNvPr id="50" name="Oval 49"/>
           <p:cNvSpPr/>
           <p:nvPr/>
         </p:nvSpPr>
         <p:spPr>
           <a:xfrm>
-            <a:off x="11521440" y="24892000"/>
+            <a:off x="11521440" y="24251920"/>
             <a:ext cx="914400" cy="914400"/>
           </a:xfrm>
           <a:prstGeom prst="ellipse">
@@ -5681,14 +5810,14 @@
       </p:sp>
       <p:sp>
         <p:nvSpPr>
-          <p:cNvPr id="47" name="TextBox 46"/>
+          <p:cNvPr id="51" name="TextBox 50"/>
           <p:cNvSpPr txBox="1"/>
           <p:nvPr/>
         </p:nvSpPr>
         <p:spPr>
           <a:xfrm>
-            <a:off x="12801600" y="24846280"/>
-            <a:ext cx="8595360" cy="1463040"/>
+            <a:off x="12801600" y="24206200"/>
+            <a:ext cx="8595360" cy="1600200"/>
           </a:xfrm>
           <a:prstGeom prst="rect">
             <a:avLst/>
@@ -5742,13 +5871,13 @@
       </p:sp>
       <p:sp>
         <p:nvSpPr>
-          <p:cNvPr id="48" name="Oval 47"/>
+          <p:cNvPr id="52" name="Oval 51"/>
           <p:cNvSpPr/>
           <p:nvPr/>
         </p:nvSpPr>
         <p:spPr>
           <a:xfrm>
-            <a:off x="11521440" y="26355040"/>
+            <a:off x="11521440" y="25852120"/>
             <a:ext cx="914400" cy="914400"/>
           </a:xfrm>
           <a:prstGeom prst="ellipse">
@@ -5795,14 +5924,14 @@
       </p:sp>
       <p:sp>
         <p:nvSpPr>
-          <p:cNvPr id="49" name="TextBox 48"/>
+          <p:cNvPr id="53" name="TextBox 52"/>
           <p:cNvSpPr txBox="1"/>
           <p:nvPr/>
         </p:nvSpPr>
         <p:spPr>
           <a:xfrm>
-            <a:off x="12801600" y="26309320"/>
-            <a:ext cx="8595360" cy="1463040"/>
+            <a:off x="12801600" y="25806400"/>
+            <a:ext cx="8595360" cy="1600200"/>
           </a:xfrm>
           <a:prstGeom prst="rect">
             <a:avLst/>
@@ -5856,13 +5985,13 @@
       </p:sp>
       <p:sp>
         <p:nvSpPr>
-          <p:cNvPr id="50" name="Oval 49"/>
+          <p:cNvPr id="54" name="Oval 53"/>
           <p:cNvSpPr/>
           <p:nvPr/>
         </p:nvSpPr>
         <p:spPr>
           <a:xfrm>
-            <a:off x="11521440" y="27818080"/>
+            <a:off x="11521440" y="27452320"/>
             <a:ext cx="914400" cy="914400"/>
           </a:xfrm>
           <a:prstGeom prst="ellipse">
@@ -5909,14 +6038,14 @@
       </p:sp>
       <p:sp>
         <p:nvSpPr>
-          <p:cNvPr id="51" name="TextBox 50"/>
+          <p:cNvPr id="55" name="TextBox 54"/>
           <p:cNvSpPr txBox="1"/>
           <p:nvPr/>
         </p:nvSpPr>
         <p:spPr>
           <a:xfrm>
-            <a:off x="12801600" y="27772360"/>
-            <a:ext cx="8595360" cy="1463040"/>
+            <a:off x="12801600" y="27406600"/>
+            <a:ext cx="8595360" cy="1600200"/>
           </a:xfrm>
           <a:prstGeom prst="rect">
             <a:avLst/>
@@ -5970,13 +6099,13 @@
       </p:sp>
       <p:sp>
         <p:nvSpPr>
-          <p:cNvPr id="52" name="Oval 51"/>
+          <p:cNvPr id="56" name="Oval 55"/>
           <p:cNvSpPr/>
           <p:nvPr/>
         </p:nvSpPr>
         <p:spPr>
           <a:xfrm>
-            <a:off x="11521440" y="29281120"/>
+            <a:off x="11521440" y="29052520"/>
             <a:ext cx="914400" cy="914400"/>
           </a:xfrm>
           <a:prstGeom prst="ellipse">
@@ -6023,14 +6152,14 @@
       </p:sp>
       <p:sp>
         <p:nvSpPr>
-          <p:cNvPr id="53" name="TextBox 52"/>
+          <p:cNvPr id="57" name="TextBox 56"/>
           <p:cNvSpPr txBox="1"/>
           <p:nvPr/>
         </p:nvSpPr>
         <p:spPr>
           <a:xfrm>
-            <a:off x="12801600" y="29235400"/>
-            <a:ext cx="8595360" cy="1463040"/>
+            <a:off x="12801600" y="29006800"/>
+            <a:ext cx="8595360" cy="1600200"/>
           </a:xfrm>
           <a:prstGeom prst="rect">
             <a:avLst/>
@@ -6084,22 +6213,22 @@
       </p:sp>
       <p:pic>
         <p:nvPicPr>
-          <p:cNvPr id="54" name="Picture 53" descr="topic7_architecture.png"/>
+          <p:cNvPr id="58" name="Picture 57" descr="topic7_architecture.png"/>
           <p:cNvPicPr>
             <a:picLocks noChangeAspect="1"/>
           </p:cNvPicPr>
           <p:nvPr/>
         </p:nvPicPr>
         <p:blipFill>
-          <a:blip r:embed="rId4"/>
+          <a:blip r:embed="rId7"/>
           <a:stretch>
             <a:fillRect/>
           </a:stretch>
         </p:blipFill>
         <p:spPr>
           <a:xfrm>
-            <a:off x="11978640" y="30835600"/>
-            <a:ext cx="8961120" cy="4971859"/>
+            <a:off x="11795760" y="30744160"/>
+            <a:ext cx="9326880" cy="5174792"/>
           </a:xfrm>
           <a:prstGeom prst="rect">
             <a:avLst/>
@@ -6113,13 +6242,13 @@
       </p:pic>
       <p:sp>
         <p:nvSpPr>
-          <p:cNvPr id="55" name="TextBox 54"/>
+          <p:cNvPr id="59" name="TextBox 58"/>
           <p:cNvSpPr txBox="1"/>
           <p:nvPr/>
         </p:nvSpPr>
         <p:spPr>
           <a:xfrm>
-            <a:off x="11521440" y="35990339"/>
+            <a:off x="11521440" y="36101832"/>
             <a:ext cx="9875520" cy="899160"/>
           </a:xfrm>
           <a:prstGeom prst="rect">
@@ -6155,13 +6284,13 @@
       </p:sp>
       <p:sp>
         <p:nvSpPr>
-          <p:cNvPr id="56" name="Rounded Rectangle 55"/>
+          <p:cNvPr id="60" name="Rounded Rectangle 59"/>
           <p:cNvSpPr/>
           <p:nvPr/>
         </p:nvSpPr>
         <p:spPr>
           <a:xfrm>
-            <a:off x="22128480" y="7040880"/>
+            <a:off x="22128480" y="6126480"/>
             <a:ext cx="9875520" cy="1234440"/>
           </a:xfrm>
           <a:prstGeom prst="roundRect">
@@ -6210,14 +6339,14 @@
       </p:sp>
       <p:sp>
         <p:nvSpPr>
-          <p:cNvPr id="57" name="Rounded Rectangle 56"/>
+          <p:cNvPr id="61" name="Rounded Rectangle 60"/>
           <p:cNvSpPr/>
           <p:nvPr/>
         </p:nvSpPr>
         <p:spPr>
           <a:xfrm>
-            <a:off x="22128480" y="8686800"/>
-            <a:ext cx="4754880" cy="2788920"/>
+            <a:off x="22128480" y="7772400"/>
+            <a:ext cx="4754880" cy="3108960"/>
           </a:xfrm>
           <a:prstGeom prst="roundRect">
             <a:avLst>
@@ -6258,14 +6387,14 @@
       </p:sp>
       <p:sp>
         <p:nvSpPr>
-          <p:cNvPr id="58" name="TextBox 57"/>
+          <p:cNvPr id="62" name="TextBox 61"/>
           <p:cNvSpPr txBox="1"/>
           <p:nvPr/>
         </p:nvSpPr>
         <p:spPr>
           <a:xfrm>
-            <a:off x="22311360" y="8823960"/>
-            <a:ext cx="4389120" cy="1394460"/>
+            <a:off x="22311360" y="7909560"/>
+            <a:ext cx="4389120" cy="1554480"/>
           </a:xfrm>
           <a:prstGeom prst="rect">
             <a:avLst/>
@@ -6287,7 +6416,7 @@
               </a:spcAft>
             </a:pPr>
             <a:r>
-              <a:rPr sz="7200" b="1" i="0">
+              <a:rPr sz="7600" b="1" i="0">
                 <a:solidFill>
                   <a:srgbClr val="522398"/>
                 </a:solidFill>
@@ -6300,14 +6429,14 @@
       </p:sp>
       <p:sp>
         <p:nvSpPr>
-          <p:cNvPr id="59" name="TextBox 58"/>
+          <p:cNvPr id="63" name="TextBox 62"/>
           <p:cNvSpPr txBox="1"/>
           <p:nvPr/>
         </p:nvSpPr>
         <p:spPr>
           <a:xfrm>
-            <a:off x="22357080" y="10220706"/>
-            <a:ext cx="4297680" cy="1171346"/>
+            <a:off x="22357080" y="9482328"/>
+            <a:ext cx="4297680" cy="1305763"/>
           </a:xfrm>
           <a:prstGeom prst="rect">
             <a:avLst/>
@@ -6342,14 +6471,14 @@
       </p:sp>
       <p:sp>
         <p:nvSpPr>
-          <p:cNvPr id="60" name="Rounded Rectangle 59"/>
+          <p:cNvPr id="64" name="Rounded Rectangle 63"/>
           <p:cNvSpPr/>
           <p:nvPr/>
         </p:nvSpPr>
         <p:spPr>
           <a:xfrm>
-            <a:off x="27249120" y="8686800"/>
-            <a:ext cx="4754880" cy="2788920"/>
+            <a:off x="27249120" y="7772400"/>
+            <a:ext cx="4754880" cy="3108960"/>
           </a:xfrm>
           <a:prstGeom prst="roundRect">
             <a:avLst>
@@ -6390,14 +6519,14 @@
       </p:sp>
       <p:sp>
         <p:nvSpPr>
-          <p:cNvPr id="61" name="TextBox 60"/>
+          <p:cNvPr id="65" name="TextBox 64"/>
           <p:cNvSpPr txBox="1"/>
           <p:nvPr/>
         </p:nvSpPr>
         <p:spPr>
           <a:xfrm>
-            <a:off x="27432000" y="8823960"/>
-            <a:ext cx="4389120" cy="1394460"/>
+            <a:off x="27432000" y="7909560"/>
+            <a:ext cx="4389120" cy="1554480"/>
           </a:xfrm>
           <a:prstGeom prst="rect">
             <a:avLst/>
@@ -6419,7 +6548,7 @@
               </a:spcAft>
             </a:pPr>
             <a:r>
-              <a:rPr sz="7200" b="1" i="0">
+              <a:rPr sz="7600" b="1" i="0">
                 <a:solidFill>
                   <a:srgbClr val="522398"/>
                 </a:solidFill>
@@ -6432,14 +6561,14 @@
       </p:sp>
       <p:sp>
         <p:nvSpPr>
-          <p:cNvPr id="62" name="TextBox 61"/>
+          <p:cNvPr id="66" name="TextBox 65"/>
           <p:cNvSpPr txBox="1"/>
           <p:nvPr/>
         </p:nvSpPr>
         <p:spPr>
           <a:xfrm>
-            <a:off x="27477720" y="10220706"/>
-            <a:ext cx="4297680" cy="1171346"/>
+            <a:off x="27477720" y="9482328"/>
+            <a:ext cx="4297680" cy="1305763"/>
           </a:xfrm>
           <a:prstGeom prst="rect">
             <a:avLst/>
@@ -6474,14 +6603,14 @@
       </p:sp>
       <p:sp>
         <p:nvSpPr>
-          <p:cNvPr id="63" name="Rounded Rectangle 62"/>
+          <p:cNvPr id="67" name="Rounded Rectangle 66"/>
           <p:cNvSpPr/>
           <p:nvPr/>
         </p:nvSpPr>
         <p:spPr>
           <a:xfrm>
-            <a:off x="22128480" y="11750040"/>
-            <a:ext cx="4754880" cy="2788920"/>
+            <a:off x="22128480" y="11247120"/>
+            <a:ext cx="4754880" cy="3108960"/>
           </a:xfrm>
           <a:prstGeom prst="roundRect">
             <a:avLst>
@@ -6522,14 +6651,14 @@
       </p:sp>
       <p:sp>
         <p:nvSpPr>
-          <p:cNvPr id="64" name="TextBox 63"/>
+          <p:cNvPr id="68" name="TextBox 67"/>
           <p:cNvSpPr txBox="1"/>
           <p:nvPr/>
         </p:nvSpPr>
         <p:spPr>
           <a:xfrm>
-            <a:off x="22311360" y="11887200"/>
-            <a:ext cx="4389120" cy="1394460"/>
+            <a:off x="22311360" y="11384280"/>
+            <a:ext cx="4389120" cy="1554480"/>
           </a:xfrm>
           <a:prstGeom prst="rect">
             <a:avLst/>
@@ -6551,7 +6680,7 @@
               </a:spcAft>
             </a:pPr>
             <a:r>
-              <a:rPr sz="7200" b="1" i="0">
+              <a:rPr sz="7600" b="1" i="0">
                 <a:solidFill>
                   <a:srgbClr val="522398"/>
                 </a:solidFill>
@@ -6564,14 +6693,14 @@
       </p:sp>
       <p:sp>
         <p:nvSpPr>
-          <p:cNvPr id="65" name="TextBox 64"/>
+          <p:cNvPr id="69" name="TextBox 68"/>
           <p:cNvSpPr txBox="1"/>
           <p:nvPr/>
         </p:nvSpPr>
         <p:spPr>
           <a:xfrm>
-            <a:off x="22357080" y="13283946"/>
-            <a:ext cx="4297680" cy="1171346"/>
+            <a:off x="22357080" y="12957048"/>
+            <a:ext cx="4297680" cy="1305763"/>
           </a:xfrm>
           <a:prstGeom prst="rect">
             <a:avLst/>
@@ -6606,14 +6735,14 @@
       </p:sp>
       <p:sp>
         <p:nvSpPr>
-          <p:cNvPr id="66" name="Rounded Rectangle 65"/>
+          <p:cNvPr id="70" name="Rounded Rectangle 69"/>
           <p:cNvSpPr/>
           <p:nvPr/>
         </p:nvSpPr>
         <p:spPr>
           <a:xfrm>
-            <a:off x="27249120" y="11750040"/>
-            <a:ext cx="4754880" cy="2788920"/>
+            <a:off x="27249120" y="11247120"/>
+            <a:ext cx="4754880" cy="3108960"/>
           </a:xfrm>
           <a:prstGeom prst="roundRect">
             <a:avLst>
@@ -6654,14 +6783,14 @@
       </p:sp>
       <p:sp>
         <p:nvSpPr>
-          <p:cNvPr id="67" name="TextBox 66"/>
+          <p:cNvPr id="71" name="TextBox 70"/>
           <p:cNvSpPr txBox="1"/>
           <p:nvPr/>
         </p:nvSpPr>
         <p:spPr>
           <a:xfrm>
-            <a:off x="27432000" y="11887200"/>
-            <a:ext cx="4389120" cy="1394460"/>
+            <a:off x="27432000" y="11384280"/>
+            <a:ext cx="4389120" cy="1554480"/>
           </a:xfrm>
           <a:prstGeom prst="rect">
             <a:avLst/>
@@ -6683,7 +6812,7 @@
               </a:spcAft>
             </a:pPr>
             <a:r>
-              <a:rPr sz="7200" b="1" i="0">
+              <a:rPr sz="7600" b="1" i="0">
                 <a:solidFill>
                   <a:srgbClr val="522398"/>
                 </a:solidFill>
@@ -6696,14 +6825,14 @@
       </p:sp>
       <p:sp>
         <p:nvSpPr>
-          <p:cNvPr id="68" name="TextBox 67"/>
+          <p:cNvPr id="72" name="TextBox 71"/>
           <p:cNvSpPr txBox="1"/>
           <p:nvPr/>
         </p:nvSpPr>
         <p:spPr>
           <a:xfrm>
-            <a:off x="27477720" y="13283946"/>
-            <a:ext cx="4297680" cy="1171346"/>
+            <a:off x="27477720" y="12957048"/>
+            <a:ext cx="4297680" cy="1305763"/>
           </a:xfrm>
           <a:prstGeom prst="rect">
             <a:avLst/>
@@ -6738,21 +6867,21 @@
       </p:sp>
       <p:pic>
         <p:nvPicPr>
-          <p:cNvPr id="69" name="Picture 68" descr="topic7_benchmarks.png"/>
+          <p:cNvPr id="73" name="Picture 72" descr="topic7_benchmarks.png"/>
           <p:cNvPicPr>
             <a:picLocks noChangeAspect="1"/>
           </p:cNvPicPr>
           <p:nvPr/>
         </p:nvPicPr>
         <p:blipFill>
-          <a:blip r:embed="rId5"/>
+          <a:blip r:embed="rId8"/>
           <a:stretch>
             <a:fillRect/>
           </a:stretch>
         </p:blipFill>
         <p:spPr>
           <a:xfrm>
-            <a:off x="22128480" y="14996159"/>
+            <a:off x="22128480" y="14904720"/>
             <a:ext cx="9875520" cy="4855188"/>
           </a:xfrm>
           <a:prstGeom prst="rect">
@@ -6767,13 +6896,13 @@
       </p:pic>
       <p:sp>
         <p:nvSpPr>
-          <p:cNvPr id="70" name="TextBox 69"/>
+          <p:cNvPr id="74" name="TextBox 73"/>
           <p:cNvSpPr txBox="1"/>
           <p:nvPr/>
         </p:nvSpPr>
         <p:spPr>
           <a:xfrm>
-            <a:off x="22128480" y="20034228"/>
+            <a:off x="22128480" y="19942788"/>
             <a:ext cx="9875520" cy="2042160"/>
           </a:xfrm>
           <a:prstGeom prst="rect">
@@ -6809,21 +6938,21 @@
       </p:sp>
       <p:pic>
         <p:nvPicPr>
-          <p:cNvPr id="71" name="Picture 70" descr="ui_poster_crop.png"/>
+          <p:cNvPr id="75" name="Picture 74" descr="ui_poster_crop.png"/>
           <p:cNvPicPr>
             <a:picLocks noChangeAspect="1"/>
           </p:cNvPicPr>
           <p:nvPr/>
         </p:nvPicPr>
         <p:blipFill>
-          <a:blip r:embed="rId6"/>
+          <a:blip r:embed="rId9"/>
           <a:stretch>
             <a:fillRect/>
           </a:stretch>
         </p:blipFill>
         <p:spPr>
           <a:xfrm>
-            <a:off x="22128480" y="22304988"/>
+            <a:off x="22128480" y="22213548"/>
             <a:ext cx="9875520" cy="4752865"/>
           </a:xfrm>
           <a:prstGeom prst="rect">
@@ -6838,13 +6967,13 @@
       </p:pic>
       <p:sp>
         <p:nvSpPr>
-          <p:cNvPr id="72" name="TextBox 71"/>
+          <p:cNvPr id="76" name="TextBox 75"/>
           <p:cNvSpPr txBox="1"/>
           <p:nvPr/>
         </p:nvSpPr>
         <p:spPr>
           <a:xfrm>
-            <a:off x="22128480" y="27240734"/>
+            <a:off x="22128480" y="27149294"/>
             <a:ext cx="9875520" cy="2042160"/>
           </a:xfrm>
           <a:prstGeom prst="rect">
@@ -6880,13 +7009,13 @@
       </p:sp>
       <p:sp>
         <p:nvSpPr>
-          <p:cNvPr id="73" name="TextBox 72"/>
+          <p:cNvPr id="77" name="TextBox 76"/>
           <p:cNvSpPr txBox="1"/>
           <p:nvPr/>
         </p:nvSpPr>
         <p:spPr>
           <a:xfrm>
-            <a:off x="22128480" y="29511494"/>
+            <a:off x="22128480" y="29420054"/>
             <a:ext cx="9875520" cy="1722119"/>
           </a:xfrm>
           <a:prstGeom prst="rect">
@@ -6931,13 +7060,13 @@
       </p:sp>
       <p:sp>
         <p:nvSpPr>
-          <p:cNvPr id="74" name="Rounded Rectangle 73"/>
+          <p:cNvPr id="78" name="Rounded Rectangle 77"/>
           <p:cNvSpPr/>
           <p:nvPr/>
         </p:nvSpPr>
         <p:spPr>
           <a:xfrm>
-            <a:off x="22128480" y="31599374"/>
+            <a:off x="22128480" y="31507934"/>
             <a:ext cx="9875520" cy="1234440"/>
           </a:xfrm>
           <a:prstGeom prst="roundRect">
@@ -6986,13 +7115,13 @@
       </p:sp>
       <p:sp>
         <p:nvSpPr>
-          <p:cNvPr id="75" name="TextBox 74"/>
+          <p:cNvPr id="79" name="TextBox 78"/>
           <p:cNvSpPr txBox="1"/>
           <p:nvPr/>
         </p:nvSpPr>
         <p:spPr>
           <a:xfrm>
-            <a:off x="22128480" y="33245294"/>
+            <a:off x="22128480" y="33153854"/>
             <a:ext cx="9875520" cy="3596640"/>
           </a:xfrm>
           <a:prstGeom prst="rect">
@@ -7105,7 +7234,7 @@
       </p:sp>
       <p:sp>
         <p:nvSpPr>
-          <p:cNvPr id="76" name="Rectangle 75"/>
+          <p:cNvPr id="80" name="Rectangle 79"/>
           <p:cNvSpPr/>
           <p:nvPr/>
         </p:nvSpPr>
@@ -7149,7 +7278,7 @@
       </p:sp>
       <p:sp>
         <p:nvSpPr>
-          <p:cNvPr id="77" name="TextBox 76"/>
+          <p:cNvPr id="81" name="TextBox 80"/>
           <p:cNvSpPr txBox="1"/>
           <p:nvPr/>
         </p:nvSpPr>
@@ -7191,7 +7320,7 @@
       </p:sp>
       <p:sp>
         <p:nvSpPr>
-          <p:cNvPr id="78" name="TextBox 77"/>
+          <p:cNvPr id="82" name="TextBox 81"/>
           <p:cNvSpPr txBox="1"/>
           <p:nvPr/>
         </p:nvSpPr>
@@ -7288,7 +7417,7 @@
       </p:sp>
       <p:sp>
         <p:nvSpPr>
-          <p:cNvPr id="79" name="TextBox 78"/>
+          <p:cNvPr id="83" name="TextBox 82"/>
           <p:cNvSpPr txBox="1"/>
           <p:nvPr/>
         </p:nvSpPr>
@@ -7385,7 +7514,7 @@
       </p:sp>
       <p:sp>
         <p:nvSpPr>
-          <p:cNvPr id="80" name="TextBox 79"/>
+          <p:cNvPr id="84" name="TextBox 83"/>
           <p:cNvSpPr txBox="1"/>
           <p:nvPr/>
         </p:nvSpPr>
@@ -7482,7 +7611,7 @@
       </p:sp>
       <p:sp>
         <p:nvSpPr>
-          <p:cNvPr id="81" name="Rectangle 80"/>
+          <p:cNvPr id="85" name="Rectangle 84"/>
           <p:cNvSpPr/>
           <p:nvPr/>
         </p:nvSpPr>
@@ -7526,7 +7655,7 @@
       </p:sp>
       <p:sp>
         <p:nvSpPr>
-          <p:cNvPr id="82" name="TextBox 81"/>
+          <p:cNvPr id="86" name="TextBox 85"/>
           <p:cNvSpPr txBox="1"/>
           <p:nvPr/>
         </p:nvSpPr>
@@ -7577,7 +7706,7 @@
       </p:sp>
       <p:sp>
         <p:nvSpPr>
-          <p:cNvPr id="83" name="TextBox 82"/>
+          <p:cNvPr id="87" name="TextBox 86"/>
           <p:cNvSpPr txBox="1"/>
           <p:nvPr/>
         </p:nvSpPr>

</xml_diff>